<commit_message>
Fix wrapped line on negatives slide
Co-Authored-By: Claude Sonnet 5.5 <noreply@anthropic.com>
Claude-Session: https://claude.ai/code/session_01Dfx5njrAxoRTBzPLGm16D8
</commit_message>
<xml_diff>
--- a/curso-ingles/book1/Book1_Unit01.pptx
+++ b/curso-ingles/book1/Book1_Unit01.pptx
@@ -9278,54 +9278,6 @@
                 <a:cs typeface="Calibri" pitchFamily="34" charset="-120"/>
               </a:rPr>
               <a:t> a doctor.</a:t>
-            </a:r>
-            <a:endParaRPr lang="en-US" sz="1600" dirty="0"/>
-          </a:p>
-          <a:p>
-            <a:pPr indent="0" marL="0">
-              <a:buNone/>
-            </a:pPr>
-            <a:r>
-              <a:rPr lang="en-US" sz="1600" dirty="0">
-                <a:solidFill>
-                  <a:srgbClr val="001737"/>
-                </a:solidFill>
-                <a:latin typeface="Calibri" pitchFamily="34" charset="0"/>
-                <a:ea typeface="Calibri" pitchFamily="34" charset="-122"/>
-                <a:cs typeface="Calibri" pitchFamily="34" charset="-120"/>
-              </a:rPr>
-              <a:t>(or You're </a:t>
-            </a:r>
-            <a:endParaRPr lang="en-US" sz="1600" dirty="0"/>
-          </a:p>
-          <a:p>
-            <a:pPr indent="0" marL="0">
-              <a:buNone/>
-            </a:pPr>
-            <a:r>
-              <a:rPr lang="en-US" sz="1600" b="1" dirty="0">
-                <a:solidFill>
-                  <a:srgbClr val="B45309"/>
-                </a:solidFill>
-                <a:latin typeface="Calibri" pitchFamily="34" charset="0"/>
-                <a:ea typeface="Calibri" pitchFamily="34" charset="-122"/>
-                <a:cs typeface="Calibri" pitchFamily="34" charset="-120"/>
-              </a:rPr>
-              <a:t>not</a:t>
-            </a:r>
-            <a:pPr indent="0" marL="0">
-              <a:buNone/>
-            </a:pPr>
-            <a:r>
-              <a:rPr lang="en-US" sz="1600" dirty="0">
-                <a:solidFill>
-                  <a:srgbClr val="001737"/>
-                </a:solidFill>
-                <a:latin typeface="Calibri" pitchFamily="34" charset="0"/>
-                <a:ea typeface="Calibri" pitchFamily="34" charset="-122"/>
-                <a:cs typeface="Calibri" pitchFamily="34" charset="-120"/>
-              </a:rPr>
-              <a:t>)</a:t>
             </a:r>
             <a:endParaRPr lang="en-US" sz="1600" dirty="0"/>
           </a:p>

</xml_diff>